<commit_message>
docs: finalize graduation submission materials
</commit_message>
<xml_diff>
--- a/docs/110122188_Slide KLTN 2026.pptx
+++ b/docs/110122188_Slide KLTN 2026.pptx
@@ -6689,7 +6689,7 @@
             </a:fld>
             <a:r>
               <a:rPr lang="en-US" altLang="en-US" sz="1200"/>
-              <a:t> / 15</a:t>
+              <a:t> / 16</a:t>
             </a:r>
           </a:p>
         </p:txBody>
@@ -7017,7 +7017,7 @@
             </a:fld>
             <a:r>
               <a:rPr lang="en-US" altLang="en-US" sz="1200"/>
-              <a:t> / 15</a:t>
+              <a:t> / 16</a:t>
             </a:r>
           </a:p>
         </p:txBody>
@@ -7352,7 +7352,7 @@
             </a:fld>
             <a:r>
               <a:rPr lang="en-US" altLang="en-US" sz="1200"/>
-              <a:t> / 15</a:t>
+              <a:t> / 16</a:t>
             </a:r>
           </a:p>
         </p:txBody>
@@ -8171,7 +8171,7 @@
             </a:fld>
             <a:r>
               <a:rPr lang="en-US" altLang="en-US" sz="1200"/>
-              <a:t> / 15</a:t>
+              <a:t> / 16</a:t>
             </a:r>
           </a:p>
         </p:txBody>
@@ -9391,7 +9391,7 @@
             </a:fld>
             <a:r>
               <a:rPr lang="en-US" altLang="en-US" sz="1200"/>
-              <a:t> / 15</a:t>
+              <a:t> / 16</a:t>
             </a:r>
           </a:p>
         </p:txBody>
@@ -9723,7 +9723,7 @@
             </a:fld>
             <a:r>
               <a:rPr lang="en-US" altLang="en-US" sz="1200"/>
-              <a:t> / 15</a:t>
+              <a:t> / 16</a:t>
             </a:r>
           </a:p>
         </p:txBody>
@@ -10115,7 +10115,7 @@
             </a:fld>
             <a:r>
               <a:rPr lang="en-US" altLang="en-US" sz="1200"/>
-              <a:t> / 15</a:t>
+              <a:t> / 16</a:t>
             </a:r>
           </a:p>
         </p:txBody>
@@ -10405,7 +10405,7 @@
             </a:fld>
             <a:r>
               <a:rPr lang="en-US" altLang="en-US" sz="1200"/>
-              <a:t> / 15</a:t>
+              <a:t> / 16</a:t>
             </a:r>
           </a:p>
         </p:txBody>
@@ -10731,7 +10731,7 @@
             </a:fld>
             <a:r>
               <a:rPr lang="en-US" altLang="en-US" sz="1200"/>
-              <a:t> / 15</a:t>
+              <a:t> / 16</a:t>
             </a:r>
           </a:p>
         </p:txBody>
@@ -11088,7 +11088,7 @@
             </a:fld>
             <a:r>
               <a:rPr lang="en-US" altLang="en-US" sz="1200"/>
-              <a:t> / 15</a:t>
+              <a:t> / 16</a:t>
             </a:r>
           </a:p>
         </p:txBody>
@@ -11437,7 +11437,7 @@
             </a:fld>
             <a:r>
               <a:rPr lang="en-US" altLang="en-US" sz="1200"/>
-              <a:t> / 15</a:t>
+              <a:t> / 16</a:t>
             </a:r>
           </a:p>
         </p:txBody>
@@ -11735,7 +11735,7 @@
             </a:fld>
             <a:r>
               <a:rPr lang="en-US" altLang="en-US" sz="1200"/>
-              <a:t> / 15</a:t>
+              <a:t> / 16</a:t>
             </a:r>
           </a:p>
         </p:txBody>
@@ -11784,7 +11784,7 @@
                 <a:latin typeface="Arial" pitchFamily="34" charset="0"/>
                 <a:cs typeface="Arial" pitchFamily="34" charset="0"/>
               </a:rPr>
-              <a:t>Kiến trúc worker</a:t>
+              <a:t>Pineline xử lý của worker</a:t>
             </a:r>
             <a:endParaRPr lang="en-US" sz="2500" dirty="0">
               <a:solidFill>
@@ -12041,7 +12041,7 @@
             </a:fld>
             <a:r>
               <a:rPr lang="en-US" altLang="en-US" sz="1200"/>
-              <a:t> / 15</a:t>
+              <a:t> / 16</a:t>
             </a:r>
           </a:p>
         </p:txBody>
@@ -12345,7 +12345,7 @@
             </a:fld>
             <a:r>
               <a:rPr lang="en-US" altLang="en-US" sz="1200"/>
-              <a:t> / 15</a:t>
+              <a:t> / 16</a:t>
             </a:r>
           </a:p>
         </p:txBody>
@@ -12837,7 +12837,7 @@
             </a:fld>
             <a:r>
               <a:rPr lang="en-US" altLang="en-US" sz="1200"/>
-              <a:t> / 15</a:t>
+              <a:t> / 16</a:t>
             </a:r>
           </a:p>
         </p:txBody>

</xml_diff>